<commit_message>
Add poster.pptx; update poster assets
Add a new poster file (poster/poster.pptx), update the existing poster/hypotheticalocean.pptx, and modify the localized DOCX asset (binary file with non-ASCII filename). These are binary asset updates for the poster materials; no source code changes.
</commit_message>
<xml_diff>
--- a/poster/hypotheticalocean.pptx
+++ b/poster/hypotheticalocean.pptx
@@ -220,7 +220,7 @@
           <a:p>
             <a:fld id="{302F586B-0015-43FB-918D-31E1A09780E3}" type="datetimeFigureOut">
               <a:rPr lang="en-US" smtClean="0"/>
-              <a:t>5/23/2026</a:t>
+              <a:t>5/26/2026</a:t>
             </a:fld>
             <a:endParaRPr lang="en-US"/>
           </a:p>
@@ -459,7 +459,7 @@
           <a:p>
             <a:fld id="{1D3EE5B7-680E-44FF-962F-3113FAB5030E}" type="datetimeFigureOut">
               <a:rPr lang="en-US" smtClean="0"/>
-              <a:t>5/23/2026</a:t>
+              <a:t>5/26/2026</a:t>
             </a:fld>
             <a:endParaRPr lang="en-US"/>
           </a:p>
@@ -658,7 +658,7 @@
           <a:p>
             <a:fld id="{1D3EE5B7-680E-44FF-962F-3113FAB5030E}" type="datetimeFigureOut">
               <a:rPr lang="en-US" smtClean="0"/>
-              <a:t>5/23/2026</a:t>
+              <a:t>5/26/2026</a:t>
             </a:fld>
             <a:endParaRPr lang="en-US"/>
           </a:p>
@@ -847,7 +847,7 @@
           <a:p>
             <a:fld id="{1D3EE5B7-680E-44FF-962F-3113FAB5030E}" type="datetimeFigureOut">
               <a:rPr lang="en-US" smtClean="0"/>
-              <a:t>5/23/2026</a:t>
+              <a:t>5/26/2026</a:t>
             </a:fld>
             <a:endParaRPr lang="en-US"/>
           </a:p>
@@ -1111,7 +1111,7 @@
           <a:p>
             <a:fld id="{1D3EE5B7-680E-44FF-962F-3113FAB5030E}" type="datetimeFigureOut">
               <a:rPr lang="en-US" smtClean="0"/>
-              <a:t>5/23/2026</a:t>
+              <a:t>5/26/2026</a:t>
             </a:fld>
             <a:endParaRPr lang="en-US"/>
           </a:p>
@@ -1419,7 +1419,7 @@
           <a:p>
             <a:fld id="{1D3EE5B7-680E-44FF-962F-3113FAB5030E}" type="datetimeFigureOut">
               <a:rPr lang="en-US" smtClean="0"/>
-              <a:t>5/23/2026</a:t>
+              <a:t>5/26/2026</a:t>
             </a:fld>
             <a:endParaRPr lang="en-US"/>
           </a:p>
@@ -1866,7 +1866,7 @@
           <a:p>
             <a:fld id="{1D3EE5B7-680E-44FF-962F-3113FAB5030E}" type="datetimeFigureOut">
               <a:rPr lang="en-US" smtClean="0"/>
-              <a:t>5/23/2026</a:t>
+              <a:t>5/26/2026</a:t>
             </a:fld>
             <a:endParaRPr lang="en-US"/>
           </a:p>
@@ -2000,7 +2000,7 @@
           <a:p>
             <a:fld id="{1D3EE5B7-680E-44FF-962F-3113FAB5030E}" type="datetimeFigureOut">
               <a:rPr lang="en-US" smtClean="0"/>
-              <a:t>5/23/2026</a:t>
+              <a:t>5/26/2026</a:t>
             </a:fld>
             <a:endParaRPr lang="en-US"/>
           </a:p>
@@ -2108,7 +2108,7 @@
           <a:p>
             <a:fld id="{1D3EE5B7-680E-44FF-962F-3113FAB5030E}" type="datetimeFigureOut">
               <a:rPr lang="en-US" smtClean="0"/>
-              <a:t>5/23/2026</a:t>
+              <a:t>5/26/2026</a:t>
             </a:fld>
             <a:endParaRPr lang="en-US"/>
           </a:p>
@@ -2405,7 +2405,7 @@
           <a:p>
             <a:fld id="{1D3EE5B7-680E-44FF-962F-3113FAB5030E}" type="datetimeFigureOut">
               <a:rPr lang="en-US" smtClean="0"/>
-              <a:t>5/23/2026</a:t>
+              <a:t>5/26/2026</a:t>
             </a:fld>
             <a:endParaRPr lang="en-US"/>
           </a:p>
@@ -2679,7 +2679,7 @@
           <a:p>
             <a:fld id="{1D3EE5B7-680E-44FF-962F-3113FAB5030E}" type="datetimeFigureOut">
               <a:rPr lang="en-US" smtClean="0"/>
-              <a:t>5/23/2026</a:t>
+              <a:t>5/26/2026</a:t>
             </a:fld>
             <a:endParaRPr lang="en-US"/>
           </a:p>
@@ -2910,7 +2910,7 @@
           <a:p>
             <a:fld id="{1D3EE5B7-680E-44FF-962F-3113FAB5030E}" type="datetimeFigureOut">
               <a:rPr lang="en-US" smtClean="0"/>
-              <a:t>5/23/2026</a:t>
+              <a:t>5/26/2026</a:t>
             </a:fld>
             <a:endParaRPr lang="en-US"/>
           </a:p>
@@ -4215,8 +4215,8 @@
         </p:nvSpPr>
         <p:spPr>
           <a:xfrm>
-            <a:off x="6152401" y="-31712"/>
-            <a:ext cx="21364396" cy="2677656"/>
+            <a:off x="5906101" y="5383"/>
+            <a:ext cx="21144944" cy="2554545"/>
           </a:xfrm>
           <a:prstGeom prst="rect">
             <a:avLst/>
@@ -4231,7 +4231,7 @@
           <a:p>
             <a:pPr algn="ctr"/>
             <a:r>
-              <a:rPr lang="he-IL" sz="8400" b="1" dirty="0">
+              <a:rPr lang="he-IL" sz="8000" b="1" dirty="0">
                 <a:solidFill>
                   <a:schemeClr val="tx2"/>
                 </a:solidFill>
@@ -4239,12 +4239,6 @@
               </a:rPr>
               <a:t>פיתוח מודל למידת מכונה לחיזוי משתני בית שורשים בחממה</a:t>
             </a:r>
-            <a:endParaRPr lang="he-IL" sz="8400" dirty="0">
-              <a:solidFill>
-                <a:schemeClr val="tx2"/>
-              </a:solidFill>
-              <a:latin typeface="+mj-lt"/>
-            </a:endParaRPr>
           </a:p>
         </p:txBody>
       </p:sp>
@@ -4262,8 +4256,8 @@
         </p:nvSpPr>
         <p:spPr>
           <a:xfrm>
-            <a:off x="4775523" y="2649523"/>
-            <a:ext cx="24118153" cy="707886"/>
+            <a:off x="3698998" y="2609690"/>
+            <a:ext cx="25348916" cy="738664"/>
           </a:xfrm>
           <a:prstGeom prst="rect">
             <a:avLst/>
@@ -4278,7 +4272,7 @@
           <a:p>
             <a:pPr algn="ctr"/>
             <a:r>
-              <a:rPr lang="he-IL" sz="4000" b="1" dirty="0">
+              <a:rPr lang="he-IL" sz="4200" b="1" dirty="0">
                 <a:solidFill>
                   <a:schemeClr val="tx2"/>
                 </a:solidFill>
@@ -4287,7 +4281,7 @@
               <a:t>סטודנטים: </a:t>
             </a:r>
             <a:r>
-              <a:rPr lang="he-IL" sz="4000" dirty="0">
+              <a:rPr lang="he-IL" sz="4200" dirty="0">
                 <a:solidFill>
                   <a:schemeClr val="tx2"/>
                 </a:solidFill>
@@ -4296,7 +4290,7 @@
               <a:t>עדן אליהו ואורן צ'אושו | </a:t>
             </a:r>
             <a:r>
-              <a:rPr lang="he-IL" sz="4000" b="1" dirty="0">
+              <a:rPr lang="he-IL" sz="4200" b="1" dirty="0">
                 <a:solidFill>
                   <a:schemeClr val="tx2"/>
                 </a:solidFill>
@@ -4305,7 +4299,7 @@
               <a:t>מוסדות: </a:t>
             </a:r>
             <a:r>
-              <a:rPr lang="he-IL" sz="4000" dirty="0">
+              <a:rPr lang="he-IL" sz="4200" dirty="0">
                 <a:solidFill>
                   <a:schemeClr val="tx2"/>
                 </a:solidFill>
@@ -4314,7 +4308,7 @@
               <a:t>המרכז האקדמי רופין ומכון וולקני | </a:t>
             </a:r>
             <a:r>
-              <a:rPr lang="he-IL" sz="4000" b="1" dirty="0">
+              <a:rPr lang="he-IL" sz="4200" b="1" dirty="0">
                 <a:solidFill>
                   <a:schemeClr val="tx2"/>
                 </a:solidFill>
@@ -4323,7 +4317,7 @@
               <a:t>מנחים: </a:t>
             </a:r>
             <a:r>
-              <a:rPr lang="he-IL" sz="4000" dirty="0">
+              <a:rPr lang="he-IL" sz="4200" dirty="0">
                 <a:solidFill>
                   <a:schemeClr val="tx2"/>
                 </a:solidFill>

</xml_diff>